<commit_message>
Nuevo estado de turno, fixes de diseño, desplegable para transición rápida a estado Finalizado o libre
</commit_message>
<xml_diff>
--- a/Diseño/Manual de marca Pali.pptx
+++ b/Diseño/Manual de marca Pali.pptx
@@ -140,12 +140,12 @@
   <p:extLst>
     <p:ext uri="{521415D9-36F7-43E2-AB2F-B90AF26B5E84}">
       <p14:sectionLst xmlns:p14="http://schemas.microsoft.com/office/powerpoint/2010/main">
-        <p14:section name="Portada" id="{82065137-82b1-823a-2c43-58d2b3e2e1bd}">
+        <p14:section name="Portada" id="{c78d5594-a6d6-fefa-1fdc-1183f09143b8}">
           <p14:sldIdLst>
             <p14:sldId id="256"/>
           </p14:sldIdLst>
         </p14:section>
-        <p14:section name="Marca" id="{77b70603-b323-4142-7442-631739da80a6}">
+        <p14:section name="Marca" id="{2394cc8d-de32-5828-2175-e86d501bf5bf}">
           <p14:sldIdLst>
             <p14:sldId id="257"/>
             <p14:sldId id="258"/>
@@ -154,7 +154,7 @@
             <p14:sldId id="261"/>
           </p14:sldIdLst>
         </p14:section>
-        <p14:section name="Logo" id="{243267ee-b4b2-eaa1-f0f0-35e1566aded6}">
+        <p14:section name="Logo" id="{2bbe0201-dd1f-cba0-99c1-cc3792ee24fe}">
           <p14:sldIdLst>
             <p14:sldId id="262"/>
             <p14:sldId id="263"/>
@@ -166,7 +166,7 @@
             <p14:sldId id="269"/>
           </p14:sldIdLst>
         </p14:section>
-        <p14:section name="Color" id="{4ee6531e-7641-b110-2a8a-e3493178563d}">
+        <p14:section name="Color" id="{bd2fe43d-0ce5-71fd-d498-f91a4d372de7}">
           <p14:sldIdLst>
             <p14:sldId id="270"/>
             <p14:sldId id="271"/>
@@ -179,7 +179,7 @@
             <p14:sldId id="278"/>
           </p14:sldIdLst>
         </p14:section>
-        <p14:section name="Tipografía" id="{60a78b4d-2923-407f-7dfb-452f64c922a2}">
+        <p14:section name="Tipografía" id="{b7facfc3-3ea2-ee08-d045-36d4d0f25cfd}">
           <p14:sldIdLst>
             <p14:sldId id="279"/>
             <p14:sldId id="280"/>
@@ -187,7 +187,7 @@
             <p14:sldId id="282"/>
           </p14:sldIdLst>
         </p14:section>
-        <p14:section name="Sistema" id="{a6807f39-6b09-b427-08f6-be49bd63ff6b}">
+        <p14:section name="Sistema" id="{5d21f891-6c1a-b59d-f6f5-54d44a24481c}">
           <p14:sldIdLst>
             <p14:sldId id="283"/>
             <p14:sldId id="284"/>
@@ -197,7 +197,7 @@
             <p14:sldId id="288"/>
           </p14:sldIdLst>
         </p14:section>
-        <p14:section name="Cierre" id="{bd7f9903-fe81-9173-6c9f-84deaa58c1c8}">
+        <p14:section name="Cierre" id="{bebbbe01-c2ae-dae9-72f9-32cf0f513f4b}">
           <p14:sldIdLst>
             <p14:sldId id="289"/>
           </p14:sldIdLst>
@@ -18920,7 +18920,7 @@
                 <a:ea typeface="IBM Plex Mono" pitchFamily="34" charset="-122"/>
                 <a:cs typeface="IBM Plex Mono" pitchFamily="34" charset="-120"/>
               </a:rPr>
-              <a:t>AGENDA · CANCHA 1 Y CANCHA 2</a:t>
+              <a:t>AGENDA · FRÍO, FIRME Y SELLADO</a:t>
             </a:r>
             <a:endParaRPr lang="en-US" sz="1000" dirty="0"/>
           </a:p>
@@ -19037,6 +19037,255 @@
                 <a:ea typeface="IBM Plex Mono" pitchFamily="34" charset="-122"/>
                 <a:cs typeface="IBM Plex Mono" pitchFamily="34" charset="-120"/>
               </a:rPr>
+              <a:t>14:00</a:t>
+            </a:r>
+            <a:endParaRPr lang="en-US" sz="1100" dirty="0"/>
+          </a:p>
+        </p:txBody>
+      </p:sp>
+      <p:sp>
+        <p:nvSpPr>
+          <p:cNvPr id="8" name="✓ Finalizado"/>
+          <p:cNvSpPr/>
+          <p:nvPr/>
+        </p:nvSpPr>
+        <p:spPr>
+          <a:xfrm>
+            <a:off x="1508760" y="2194560"/>
+            <a:ext cx="2606040" cy="896112"/>
+          </a:xfrm>
+          <a:prstGeom prst="roundRect">
+            <a:avLst>
+              <a:gd name="adj" fmla="val 10204"/>
+            </a:avLst>
+          </a:prstGeom>
+          <a:solidFill>
+            <a:srgbClr val="6BAEE8"/>
+          </a:solidFill>
+          <a:ln w="12700">
+            <a:solidFill>
+              <a:srgbClr val="6BAEE8"/>
+            </a:solidFill>
+            <a:prstDash val="solid"/>
+          </a:ln>
+        </p:spPr>
+      </p:sp>
+      <p:sp>
+        <p:nvSpPr>
+          <p:cNvPr id="9" name="Text 7"/>
+          <p:cNvSpPr txBox="1"/>
+          <p:nvPr/>
+        </p:nvSpPr>
+        <p:spPr>
+          <a:xfrm>
+            <a:off x="1673352" y="2350008"/>
+            <a:ext cx="2331720" cy="228600"/>
+          </a:xfrm>
+          <a:prstGeom prst="rect">
+            <a:avLst/>
+          </a:prstGeom>
+          <a:noFill/>
+          <a:ln/>
+        </p:spPr>
+        <p:txBody>
+          <a:bodyPr wrap="square" lIns="0" tIns="0" rIns="0" bIns="0" rtlCol="0" anchor="t"/>
+          <a:lstStyle/>
+          <a:p>
+            <a:pPr indent="0" marL="0">
+              <a:buNone/>
+            </a:pPr>
+            <a:r>
+              <a:rPr lang="en-US" sz="900" b="1" spc="100" kern="0" dirty="0">
+                <a:solidFill>
+                  <a:srgbClr val="0D1F18"/>
+                </a:solidFill>
+                <a:latin typeface="IBM Plex Mono" pitchFamily="34" charset="0"/>
+                <a:ea typeface="IBM Plex Mono" pitchFamily="34" charset="-122"/>
+                <a:cs typeface="IBM Plex Mono" pitchFamily="34" charset="-120"/>
+              </a:rPr>
+              <a:t>✓ FINALIZADO</a:t>
+            </a:r>
+            <a:endParaRPr lang="en-US" sz="900" dirty="0"/>
+          </a:p>
+        </p:txBody>
+      </p:sp>
+      <p:sp>
+        <p:nvSpPr>
+          <p:cNvPr id="10" name="Text 8"/>
+          <p:cNvSpPr txBox="1"/>
+          <p:nvPr/>
+        </p:nvSpPr>
+        <p:spPr>
+          <a:xfrm>
+            <a:off x="1673352" y="2670048"/>
+            <a:ext cx="2331720" cy="274320"/>
+          </a:xfrm>
+          <a:prstGeom prst="rect">
+            <a:avLst/>
+          </a:prstGeom>
+          <a:noFill/>
+          <a:ln/>
+        </p:spPr>
+        <p:txBody>
+          <a:bodyPr wrap="square" lIns="0" tIns="0" rIns="0" bIns="0" rtlCol="0" anchor="t"/>
+          <a:lstStyle/>
+          <a:p>
+            <a:pPr indent="0" marL="0">
+              <a:buNone/>
+            </a:pPr>
+            <a:r>
+              <a:rPr lang="en-US" sz="1200" dirty="0">
+                <a:solidFill>
+                  <a:srgbClr val="0D1F18"/>
+                </a:solidFill>
+                <a:latin typeface="IBM Plex Sans" pitchFamily="34" charset="0"/>
+                <a:ea typeface="IBM Plex Sans" pitchFamily="34" charset="-122"/>
+                <a:cs typeface="IBM Plex Sans" pitchFamily="34" charset="-120"/>
+              </a:rPr>
+              <a:t>4 personas · cobrado</a:t>
+            </a:r>
+            <a:endParaRPr lang="en-US" sz="1200" dirty="0"/>
+          </a:p>
+        </p:txBody>
+      </p:sp>
+      <p:sp>
+        <p:nvSpPr>
+          <p:cNvPr id="11" name="✓ Finalizado"/>
+          <p:cNvSpPr/>
+          <p:nvPr/>
+        </p:nvSpPr>
+        <p:spPr>
+          <a:xfrm>
+            <a:off x="4206240" y="2194560"/>
+            <a:ext cx="2606040" cy="896112"/>
+          </a:xfrm>
+          <a:prstGeom prst="roundRect">
+            <a:avLst>
+              <a:gd name="adj" fmla="val 10204"/>
+            </a:avLst>
+          </a:prstGeom>
+          <a:solidFill>
+            <a:srgbClr val="6BAEE8"/>
+          </a:solidFill>
+          <a:ln w="12700">
+            <a:solidFill>
+              <a:srgbClr val="6BAEE8"/>
+            </a:solidFill>
+            <a:prstDash val="solid"/>
+          </a:ln>
+        </p:spPr>
+      </p:sp>
+      <p:sp>
+        <p:nvSpPr>
+          <p:cNvPr id="12" name="Text 10"/>
+          <p:cNvSpPr txBox="1"/>
+          <p:nvPr/>
+        </p:nvSpPr>
+        <p:spPr>
+          <a:xfrm>
+            <a:off x="4370832" y="2350008"/>
+            <a:ext cx="2331720" cy="228600"/>
+          </a:xfrm>
+          <a:prstGeom prst="rect">
+            <a:avLst/>
+          </a:prstGeom>
+          <a:noFill/>
+          <a:ln/>
+        </p:spPr>
+        <p:txBody>
+          <a:bodyPr wrap="square" lIns="0" tIns="0" rIns="0" bIns="0" rtlCol="0" anchor="t"/>
+          <a:lstStyle/>
+          <a:p>
+            <a:pPr indent="0" marL="0">
+              <a:buNone/>
+            </a:pPr>
+            <a:r>
+              <a:rPr lang="en-US" sz="900" b="1" spc="100" kern="0" dirty="0">
+                <a:solidFill>
+                  <a:srgbClr val="0D1F18"/>
+                </a:solidFill>
+                <a:latin typeface="IBM Plex Mono" pitchFamily="34" charset="0"/>
+                <a:ea typeface="IBM Plex Mono" pitchFamily="34" charset="-122"/>
+                <a:cs typeface="IBM Plex Mono" pitchFamily="34" charset="-120"/>
+              </a:rPr>
+              <a:t>✓ FINALIZADO</a:t>
+            </a:r>
+            <a:endParaRPr lang="en-US" sz="900" dirty="0"/>
+          </a:p>
+        </p:txBody>
+      </p:sp>
+      <p:sp>
+        <p:nvSpPr>
+          <p:cNvPr id="13" name="Text 11"/>
+          <p:cNvSpPr txBox="1"/>
+          <p:nvPr/>
+        </p:nvSpPr>
+        <p:spPr>
+          <a:xfrm>
+            <a:off x="4370832" y="2670048"/>
+            <a:ext cx="2331720" cy="274320"/>
+          </a:xfrm>
+          <a:prstGeom prst="rect">
+            <a:avLst/>
+          </a:prstGeom>
+          <a:noFill/>
+          <a:ln/>
+        </p:spPr>
+        <p:txBody>
+          <a:bodyPr wrap="square" lIns="0" tIns="0" rIns="0" bIns="0" rtlCol="0" anchor="t"/>
+          <a:lstStyle/>
+          <a:p>
+            <a:pPr indent="0" marL="0">
+              <a:buNone/>
+            </a:pPr>
+            <a:r>
+              <a:rPr lang="en-US" sz="1200" dirty="0">
+                <a:solidFill>
+                  <a:srgbClr val="0D1F18"/>
+                </a:solidFill>
+                <a:latin typeface="IBM Plex Sans" pitchFamily="34" charset="0"/>
+                <a:ea typeface="IBM Plex Sans" pitchFamily="34" charset="-122"/>
+                <a:cs typeface="IBM Plex Sans" pitchFamily="34" charset="-120"/>
+              </a:rPr>
+              <a:t>6 personas · cobrado</a:t>
+            </a:r>
+            <a:endParaRPr lang="en-US" sz="1200" dirty="0"/>
+          </a:p>
+        </p:txBody>
+      </p:sp>
+      <p:sp>
+        <p:nvSpPr>
+          <p:cNvPr id="14" name="Text 12"/>
+          <p:cNvSpPr txBox="1"/>
+          <p:nvPr/>
+        </p:nvSpPr>
+        <p:spPr>
+          <a:xfrm>
+            <a:off x="640080" y="3502152"/>
+            <a:ext cx="777240" cy="274320"/>
+          </a:xfrm>
+          <a:prstGeom prst="rect">
+            <a:avLst/>
+          </a:prstGeom>
+          <a:noFill/>
+          <a:ln/>
+        </p:spPr>
+        <p:txBody>
+          <a:bodyPr wrap="square" lIns="0" tIns="0" rIns="0" bIns="0" rtlCol="0" anchor="t"/>
+          <a:lstStyle/>
+          <a:p>
+            <a:pPr indent="0" marL="0">
+              <a:buNone/>
+            </a:pPr>
+            <a:r>
+              <a:rPr lang="en-US" sz="1100" spc="100" kern="0" dirty="0">
+                <a:solidFill>
+                  <a:srgbClr val="6A7B74"/>
+                </a:solidFill>
+                <a:latin typeface="IBM Plex Mono" pitchFamily="34" charset="0"/>
+                <a:ea typeface="IBM Plex Mono" pitchFamily="34" charset="-122"/>
+                <a:cs typeface="IBM Plex Mono" pitchFamily="34" charset="-120"/>
+              </a:rPr>
               <a:t>17:00</a:t>
             </a:r>
             <a:endParaRPr lang="en-US" sz="1100" dirty="0"/>
@@ -19045,13 +19294,511 @@
       </p:sp>
       <p:sp>
         <p:nvSpPr>
-          <p:cNvPr id="8" name="Libre"/>
+          <p:cNvPr id="15" name="Completo"/>
           <p:cNvSpPr/>
           <p:nvPr/>
         </p:nvSpPr>
         <p:spPr>
           <a:xfrm>
-            <a:off x="1508760" y="2194560"/>
+            <a:off x="1508760" y="3182112"/>
+            <a:ext cx="2606040" cy="896112"/>
+          </a:xfrm>
+          <a:prstGeom prst="roundRect">
+            <a:avLst>
+              <a:gd name="adj" fmla="val 10204"/>
+            </a:avLst>
+          </a:prstGeom>
+          <a:solidFill>
+            <a:srgbClr val="0F3D2E"/>
+          </a:solidFill>
+          <a:ln w="12700">
+            <a:solidFill>
+              <a:srgbClr val="0F3D2E"/>
+            </a:solidFill>
+            <a:prstDash val="solid"/>
+          </a:ln>
+        </p:spPr>
+      </p:sp>
+      <p:sp>
+        <p:nvSpPr>
+          <p:cNvPr id="16" name="Text 14"/>
+          <p:cNvSpPr txBox="1"/>
+          <p:nvPr/>
+        </p:nvSpPr>
+        <p:spPr>
+          <a:xfrm>
+            <a:off x="1673352" y="3337560"/>
+            <a:ext cx="2331720" cy="228600"/>
+          </a:xfrm>
+          <a:prstGeom prst="rect">
+            <a:avLst/>
+          </a:prstGeom>
+          <a:noFill/>
+          <a:ln/>
+        </p:spPr>
+        <p:txBody>
+          <a:bodyPr wrap="square" lIns="0" tIns="0" rIns="0" bIns="0" rtlCol="0" anchor="t"/>
+          <a:lstStyle/>
+          <a:p>
+            <a:pPr indent="0" marL="0">
+              <a:buNone/>
+            </a:pPr>
+            <a:r>
+              <a:rPr lang="en-US" sz="900" b="1" spc="100" kern="0" dirty="0">
+                <a:solidFill>
+                  <a:srgbClr val="FFFFFF"/>
+                </a:solidFill>
+                <a:latin typeface="IBM Plex Mono" pitchFamily="34" charset="0"/>
+                <a:ea typeface="IBM Plex Mono" pitchFamily="34" charset="-122"/>
+                <a:cs typeface="IBM Plex Mono" pitchFamily="34" charset="-120"/>
+              </a:rPr>
+              <a:t>COMPLETO</a:t>
+            </a:r>
+            <a:endParaRPr lang="en-US" sz="900" dirty="0"/>
+          </a:p>
+        </p:txBody>
+      </p:sp>
+      <p:sp>
+        <p:nvSpPr>
+          <p:cNvPr id="17" name="Text 15"/>
+          <p:cNvSpPr txBox="1"/>
+          <p:nvPr/>
+        </p:nvSpPr>
+        <p:spPr>
+          <a:xfrm>
+            <a:off x="1673352" y="3657600"/>
+            <a:ext cx="2331720" cy="274320"/>
+          </a:xfrm>
+          <a:prstGeom prst="rect">
+            <a:avLst/>
+          </a:prstGeom>
+          <a:noFill/>
+          <a:ln/>
+        </p:spPr>
+        <p:txBody>
+          <a:bodyPr wrap="square" lIns="0" tIns="0" rIns="0" bIns="0" rtlCol="0" anchor="t"/>
+          <a:lstStyle/>
+          <a:p>
+            <a:pPr indent="0" marL="0">
+              <a:buNone/>
+            </a:pPr>
+            <a:r>
+              <a:rPr lang="en-US" sz="1200" dirty="0">
+                <a:solidFill>
+                  <a:srgbClr val="A9D6C4"/>
+                </a:solidFill>
+                <a:latin typeface="IBM Plex Sans" pitchFamily="34" charset="0"/>
+                <a:ea typeface="IBM Plex Sans" pitchFamily="34" charset="-122"/>
+                <a:cs typeface="IBM Plex Sans" pitchFamily="34" charset="-120"/>
+              </a:rPr>
+              <a:t>5 personas · confirmado</a:t>
+            </a:r>
+            <a:endParaRPr lang="en-US" sz="1200" dirty="0"/>
+          </a:p>
+        </p:txBody>
+      </p:sp>
+      <p:sp>
+        <p:nvSpPr>
+          <p:cNvPr id="18" name="Reservado"/>
+          <p:cNvSpPr/>
+          <p:nvPr/>
+        </p:nvSpPr>
+        <p:spPr>
+          <a:xfrm>
+            <a:off x="4206240" y="3182112"/>
+            <a:ext cx="2606040" cy="896112"/>
+          </a:xfrm>
+          <a:prstGeom prst="roundRect">
+            <a:avLst>
+              <a:gd name="adj" fmla="val 10204"/>
+            </a:avLst>
+          </a:prstGeom>
+          <a:solidFill>
+            <a:srgbClr val="E8F4EE"/>
+          </a:solidFill>
+          <a:ln w="15875">
+            <a:solidFill>
+              <a:srgbClr val="BCDCCB"/>
+            </a:solidFill>
+            <a:prstDash val="dash"/>
+          </a:ln>
+        </p:spPr>
+      </p:sp>
+      <p:sp>
+        <p:nvSpPr>
+          <p:cNvPr id="19" name="Text 17"/>
+          <p:cNvSpPr txBox="1"/>
+          <p:nvPr/>
+        </p:nvSpPr>
+        <p:spPr>
+          <a:xfrm>
+            <a:off x="4370832" y="3337560"/>
+            <a:ext cx="2331720" cy="228600"/>
+          </a:xfrm>
+          <a:prstGeom prst="rect">
+            <a:avLst/>
+          </a:prstGeom>
+          <a:noFill/>
+          <a:ln/>
+        </p:spPr>
+        <p:txBody>
+          <a:bodyPr wrap="square" lIns="0" tIns="0" rIns="0" bIns="0" rtlCol="0" anchor="t"/>
+          <a:lstStyle/>
+          <a:p>
+            <a:pPr indent="0" marL="0">
+              <a:buNone/>
+            </a:pPr>
+            <a:r>
+              <a:rPr lang="en-US" sz="900" b="1" spc="100" kern="0" dirty="0">
+                <a:solidFill>
+                  <a:srgbClr val="1F6F57"/>
+                </a:solidFill>
+                <a:latin typeface="IBM Plex Mono" pitchFamily="34" charset="0"/>
+                <a:ea typeface="IBM Plex Mono" pitchFamily="34" charset="-122"/>
+                <a:cs typeface="IBM Plex Mono" pitchFamily="34" charset="-120"/>
+              </a:rPr>
+              <a:t>RESERVADO</a:t>
+            </a:r>
+            <a:endParaRPr lang="en-US" sz="900" dirty="0"/>
+          </a:p>
+        </p:txBody>
+      </p:sp>
+      <p:sp>
+        <p:nvSpPr>
+          <p:cNvPr id="20" name="Text 18"/>
+          <p:cNvSpPr txBox="1"/>
+          <p:nvPr/>
+        </p:nvSpPr>
+        <p:spPr>
+          <a:xfrm>
+            <a:off x="4370832" y="3657600"/>
+            <a:ext cx="2331720" cy="274320"/>
+          </a:xfrm>
+          <a:prstGeom prst="rect">
+            <a:avLst/>
+          </a:prstGeom>
+          <a:noFill/>
+          <a:ln/>
+        </p:spPr>
+        <p:txBody>
+          <a:bodyPr wrap="square" lIns="0" tIns="0" rIns="0" bIns="0" rtlCol="0" anchor="t"/>
+          <a:lstStyle/>
+          <a:p>
+            <a:pPr indent="0" marL="0">
+              <a:buNone/>
+            </a:pPr>
+            <a:r>
+              <a:rPr lang="en-US" sz="1200" dirty="0">
+                <a:solidFill>
+                  <a:srgbClr val="1F6F57"/>
+                </a:solidFill>
+                <a:latin typeface="IBM Plex Sans" pitchFamily="34" charset="0"/>
+                <a:ea typeface="IBM Plex Sans" pitchFamily="34" charset="-122"/>
+                <a:cs typeface="IBM Plex Sans" pitchFamily="34" charset="-120"/>
+              </a:rPr>
+              <a:t>2 personas · sin confirmar</a:t>
+            </a:r>
+            <a:endParaRPr lang="en-US" sz="1200" dirty="0"/>
+          </a:p>
+        </p:txBody>
+      </p:sp>
+      <p:sp>
+        <p:nvSpPr>
+          <p:cNvPr id="21" name="Text 19"/>
+          <p:cNvSpPr txBox="1"/>
+          <p:nvPr/>
+        </p:nvSpPr>
+        <p:spPr>
+          <a:xfrm>
+            <a:off x="640080" y="4489704"/>
+            <a:ext cx="777240" cy="274320"/>
+          </a:xfrm>
+          <a:prstGeom prst="rect">
+            <a:avLst/>
+          </a:prstGeom>
+          <a:noFill/>
+          <a:ln/>
+        </p:spPr>
+        <p:txBody>
+          <a:bodyPr wrap="square" lIns="0" tIns="0" rIns="0" bIns="0" rtlCol="0" anchor="t"/>
+          <a:lstStyle/>
+          <a:p>
+            <a:pPr indent="0" marL="0">
+              <a:buNone/>
+            </a:pPr>
+            <a:r>
+              <a:rPr lang="en-US" sz="1100" spc="100" kern="0" dirty="0">
+                <a:solidFill>
+                  <a:srgbClr val="6A7B74"/>
+                </a:solidFill>
+                <a:latin typeface="IBM Plex Mono" pitchFamily="34" charset="0"/>
+                <a:ea typeface="IBM Plex Mono" pitchFamily="34" charset="-122"/>
+                <a:cs typeface="IBM Plex Mono" pitchFamily="34" charset="-120"/>
+              </a:rPr>
+              <a:t>18:30</a:t>
+            </a:r>
+            <a:endParaRPr lang="en-US" sz="1100" dirty="0"/>
+          </a:p>
+        </p:txBody>
+      </p:sp>
+      <p:sp>
+        <p:nvSpPr>
+          <p:cNvPr id="22" name="Reservado"/>
+          <p:cNvSpPr/>
+          <p:nvPr/>
+        </p:nvSpPr>
+        <p:spPr>
+          <a:xfrm>
+            <a:off x="1508760" y="4169664"/>
+            <a:ext cx="2606040" cy="896112"/>
+          </a:xfrm>
+          <a:prstGeom prst="roundRect">
+            <a:avLst>
+              <a:gd name="adj" fmla="val 10204"/>
+            </a:avLst>
+          </a:prstGeom>
+          <a:solidFill>
+            <a:srgbClr val="E8F4EE"/>
+          </a:solidFill>
+          <a:ln w="15875">
+            <a:solidFill>
+              <a:srgbClr val="BCDCCB"/>
+            </a:solidFill>
+            <a:prstDash val="dash"/>
+          </a:ln>
+        </p:spPr>
+      </p:sp>
+      <p:sp>
+        <p:nvSpPr>
+          <p:cNvPr id="23" name="Text 21"/>
+          <p:cNvSpPr txBox="1"/>
+          <p:nvPr/>
+        </p:nvSpPr>
+        <p:spPr>
+          <a:xfrm>
+            <a:off x="1673352" y="4325112"/>
+            <a:ext cx="2331720" cy="228600"/>
+          </a:xfrm>
+          <a:prstGeom prst="rect">
+            <a:avLst/>
+          </a:prstGeom>
+          <a:noFill/>
+          <a:ln/>
+        </p:spPr>
+        <p:txBody>
+          <a:bodyPr wrap="square" lIns="0" tIns="0" rIns="0" bIns="0" rtlCol="0" anchor="t"/>
+          <a:lstStyle/>
+          <a:p>
+            <a:pPr indent="0" marL="0">
+              <a:buNone/>
+            </a:pPr>
+            <a:r>
+              <a:rPr lang="en-US" sz="900" b="1" spc="100" kern="0" dirty="0">
+                <a:solidFill>
+                  <a:srgbClr val="1F6F57"/>
+                </a:solidFill>
+                <a:latin typeface="IBM Plex Mono" pitchFamily="34" charset="0"/>
+                <a:ea typeface="IBM Plex Mono" pitchFamily="34" charset="-122"/>
+                <a:cs typeface="IBM Plex Mono" pitchFamily="34" charset="-120"/>
+              </a:rPr>
+              <a:t>RESERVADO</a:t>
+            </a:r>
+            <a:endParaRPr lang="en-US" sz="900" dirty="0"/>
+          </a:p>
+        </p:txBody>
+      </p:sp>
+      <p:sp>
+        <p:nvSpPr>
+          <p:cNvPr id="24" name="Text 22"/>
+          <p:cNvSpPr txBox="1"/>
+          <p:nvPr/>
+        </p:nvSpPr>
+        <p:spPr>
+          <a:xfrm>
+            <a:off x="1673352" y="4645152"/>
+            <a:ext cx="2331720" cy="274320"/>
+          </a:xfrm>
+          <a:prstGeom prst="rect">
+            <a:avLst/>
+          </a:prstGeom>
+          <a:noFill/>
+          <a:ln/>
+        </p:spPr>
+        <p:txBody>
+          <a:bodyPr wrap="square" lIns="0" tIns="0" rIns="0" bIns="0" rtlCol="0" anchor="t"/>
+          <a:lstStyle/>
+          <a:p>
+            <a:pPr indent="0" marL="0">
+              <a:buNone/>
+            </a:pPr>
+            <a:r>
+              <a:rPr lang="en-US" sz="1200" dirty="0">
+                <a:solidFill>
+                  <a:srgbClr val="1F6F57"/>
+                </a:solidFill>
+                <a:latin typeface="IBM Plex Sans" pitchFamily="34" charset="0"/>
+                <a:ea typeface="IBM Plex Sans" pitchFamily="34" charset="-122"/>
+                <a:cs typeface="IBM Plex Sans" pitchFamily="34" charset="-120"/>
+              </a:rPr>
+              <a:t>3 personas · sin confirmar</a:t>
+            </a:r>
+            <a:endParaRPr lang="en-US" sz="1200" dirty="0"/>
+          </a:p>
+        </p:txBody>
+      </p:sp>
+      <p:sp>
+        <p:nvSpPr>
+          <p:cNvPr id="25" name="Completo"/>
+          <p:cNvSpPr/>
+          <p:nvPr/>
+        </p:nvSpPr>
+        <p:spPr>
+          <a:xfrm>
+            <a:off x="4206240" y="4169664"/>
+            <a:ext cx="2606040" cy="896112"/>
+          </a:xfrm>
+          <a:prstGeom prst="roundRect">
+            <a:avLst>
+              <a:gd name="adj" fmla="val 10204"/>
+            </a:avLst>
+          </a:prstGeom>
+          <a:solidFill>
+            <a:srgbClr val="0F3D2E"/>
+          </a:solidFill>
+          <a:ln w="12700">
+            <a:solidFill>
+              <a:srgbClr val="0F3D2E"/>
+            </a:solidFill>
+            <a:prstDash val="solid"/>
+          </a:ln>
+        </p:spPr>
+      </p:sp>
+      <p:sp>
+        <p:nvSpPr>
+          <p:cNvPr id="26" name="Text 24"/>
+          <p:cNvSpPr txBox="1"/>
+          <p:nvPr/>
+        </p:nvSpPr>
+        <p:spPr>
+          <a:xfrm>
+            <a:off x="4370832" y="4325112"/>
+            <a:ext cx="2331720" cy="228600"/>
+          </a:xfrm>
+          <a:prstGeom prst="rect">
+            <a:avLst/>
+          </a:prstGeom>
+          <a:noFill/>
+          <a:ln/>
+        </p:spPr>
+        <p:txBody>
+          <a:bodyPr wrap="square" lIns="0" tIns="0" rIns="0" bIns="0" rtlCol="0" anchor="t"/>
+          <a:lstStyle/>
+          <a:p>
+            <a:pPr indent="0" marL="0">
+              <a:buNone/>
+            </a:pPr>
+            <a:r>
+              <a:rPr lang="en-US" sz="900" b="1" spc="100" kern="0" dirty="0">
+                <a:solidFill>
+                  <a:srgbClr val="FFFFFF"/>
+                </a:solidFill>
+                <a:latin typeface="IBM Plex Mono" pitchFamily="34" charset="0"/>
+                <a:ea typeface="IBM Plex Mono" pitchFamily="34" charset="-122"/>
+                <a:cs typeface="IBM Plex Mono" pitchFamily="34" charset="-120"/>
+              </a:rPr>
+              <a:t>COMPLETO</a:t>
+            </a:r>
+            <a:endParaRPr lang="en-US" sz="900" dirty="0"/>
+          </a:p>
+        </p:txBody>
+      </p:sp>
+      <p:sp>
+        <p:nvSpPr>
+          <p:cNvPr id="27" name="Text 25"/>
+          <p:cNvSpPr txBox="1"/>
+          <p:nvPr/>
+        </p:nvSpPr>
+        <p:spPr>
+          <a:xfrm>
+            <a:off x="4370832" y="4645152"/>
+            <a:ext cx="2331720" cy="274320"/>
+          </a:xfrm>
+          <a:prstGeom prst="rect">
+            <a:avLst/>
+          </a:prstGeom>
+          <a:noFill/>
+          <a:ln/>
+        </p:spPr>
+        <p:txBody>
+          <a:bodyPr wrap="square" lIns="0" tIns="0" rIns="0" bIns="0" rtlCol="0" anchor="t"/>
+          <a:lstStyle/>
+          <a:p>
+            <a:pPr indent="0" marL="0">
+              <a:buNone/>
+            </a:pPr>
+            <a:r>
+              <a:rPr lang="en-US" sz="1200" dirty="0">
+                <a:solidFill>
+                  <a:srgbClr val="A9D6C4"/>
+                </a:solidFill>
+                <a:latin typeface="IBM Plex Sans" pitchFamily="34" charset="0"/>
+                <a:ea typeface="IBM Plex Sans" pitchFamily="34" charset="-122"/>
+                <a:cs typeface="IBM Plex Sans" pitchFamily="34" charset="-120"/>
+              </a:rPr>
+              <a:t>6 personas · confirmado</a:t>
+            </a:r>
+            <a:endParaRPr lang="en-US" sz="1200" dirty="0"/>
+          </a:p>
+        </p:txBody>
+      </p:sp>
+      <p:sp>
+        <p:nvSpPr>
+          <p:cNvPr id="28" name="Text 26"/>
+          <p:cNvSpPr txBox="1"/>
+          <p:nvPr/>
+        </p:nvSpPr>
+        <p:spPr>
+          <a:xfrm>
+            <a:off x="640080" y="5477256"/>
+            <a:ext cx="777240" cy="274320"/>
+          </a:xfrm>
+          <a:prstGeom prst="rect">
+            <a:avLst/>
+          </a:prstGeom>
+          <a:noFill/>
+          <a:ln/>
+        </p:spPr>
+        <p:txBody>
+          <a:bodyPr wrap="square" lIns="0" tIns="0" rIns="0" bIns="0" rtlCol="0" anchor="t"/>
+          <a:lstStyle/>
+          <a:p>
+            <a:pPr indent="0" marL="0">
+              <a:buNone/>
+            </a:pPr>
+            <a:r>
+              <a:rPr lang="en-US" sz="1100" spc="100" kern="0" dirty="0">
+                <a:solidFill>
+                  <a:srgbClr val="6A7B74"/>
+                </a:solidFill>
+                <a:latin typeface="IBM Plex Mono" pitchFamily="34" charset="0"/>
+                <a:ea typeface="IBM Plex Mono" pitchFamily="34" charset="-122"/>
+                <a:cs typeface="IBM Plex Mono" pitchFamily="34" charset="-120"/>
+              </a:rPr>
+              <a:t>21:30</a:t>
+            </a:r>
+            <a:endParaRPr lang="en-US" sz="1100" dirty="0"/>
+          </a:p>
+        </p:txBody>
+      </p:sp>
+      <p:sp>
+        <p:nvSpPr>
+          <p:cNvPr id="29" name="Libre"/>
+          <p:cNvSpPr/>
+          <p:nvPr/>
+        </p:nvSpPr>
+        <p:spPr>
+          <a:xfrm>
+            <a:off x="1508760" y="5157216"/>
             <a:ext cx="2606040" cy="896112"/>
           </a:xfrm>
           <a:prstGeom prst="roundRect">
@@ -19072,13 +19819,13 @@
       </p:sp>
       <p:sp>
         <p:nvSpPr>
-          <p:cNvPr id="9" name="Text 7"/>
-          <p:cNvSpPr txBox="1"/>
-          <p:nvPr/>
-        </p:nvSpPr>
-        <p:spPr>
-          <a:xfrm>
-            <a:off x="1673352" y="2350008"/>
+          <p:cNvPr id="30" name="Text 28"/>
+          <p:cNvSpPr txBox="1"/>
+          <p:nvPr/>
+        </p:nvSpPr>
+        <p:spPr>
+          <a:xfrm>
+            <a:off x="1673352" y="5312664"/>
             <a:ext cx="2331720" cy="228600"/>
           </a:xfrm>
           <a:prstGeom prst="rect">
@@ -19111,13 +19858,13 @@
       </p:sp>
       <p:sp>
         <p:nvSpPr>
-          <p:cNvPr id="10" name="Text 8"/>
-          <p:cNvSpPr txBox="1"/>
-          <p:nvPr/>
-        </p:nvSpPr>
-        <p:spPr>
-          <a:xfrm>
-            <a:off x="1673352" y="2670048"/>
+          <p:cNvPr id="31" name="Text 29"/>
+          <p:cNvSpPr txBox="1"/>
+          <p:nvPr/>
+        </p:nvSpPr>
+        <p:spPr>
+          <a:xfrm>
+            <a:off x="1673352" y="5632704"/>
             <a:ext cx="2331720" cy="274320"/>
           </a:xfrm>
           <a:prstGeom prst="rect">
@@ -19142,7 +19889,7 @@
                 <a:ea typeface="IBM Plex Sans" pitchFamily="34" charset="-122"/>
                 <a:cs typeface="IBM Plex Sans" pitchFamily="34" charset="-120"/>
               </a:rPr>
-              <a:t>0 de 4 personas</a:t>
+              <a:t>Tocá para reservar</a:t>
             </a:r>
             <a:endParaRPr lang="en-US" sz="1200" dirty="0"/>
           </a:p>
@@ -19150,655 +19897,13 @@
       </p:sp>
       <p:sp>
         <p:nvSpPr>
-          <p:cNvPr id="11" name="Reservado"/>
+          <p:cNvPr id="32" name="Libre"/>
           <p:cNvSpPr/>
           <p:nvPr/>
         </p:nvSpPr>
         <p:spPr>
           <a:xfrm>
-            <a:off x="4206240" y="2194560"/>
-            <a:ext cx="2606040" cy="896112"/>
-          </a:xfrm>
-          <a:prstGeom prst="roundRect">
-            <a:avLst>
-              <a:gd name="adj" fmla="val 10204"/>
-            </a:avLst>
-          </a:prstGeom>
-          <a:solidFill>
-            <a:srgbClr val="E8F4EE"/>
-          </a:solidFill>
-          <a:ln w="15875">
-            <a:solidFill>
-              <a:srgbClr val="BCDCCB"/>
-            </a:solidFill>
-            <a:prstDash val="solid"/>
-          </a:ln>
-        </p:spPr>
-      </p:sp>
-      <p:sp>
-        <p:nvSpPr>
-          <p:cNvPr id="12" name="Text 10"/>
-          <p:cNvSpPr txBox="1"/>
-          <p:nvPr/>
-        </p:nvSpPr>
-        <p:spPr>
-          <a:xfrm>
-            <a:off x="4370832" y="2350008"/>
-            <a:ext cx="2331720" cy="228600"/>
-          </a:xfrm>
-          <a:prstGeom prst="rect">
-            <a:avLst/>
-          </a:prstGeom>
-          <a:noFill/>
-          <a:ln/>
-        </p:spPr>
-        <p:txBody>
-          <a:bodyPr wrap="square" lIns="0" tIns="0" rIns="0" bIns="0" rtlCol="0" anchor="t"/>
-          <a:lstStyle/>
-          <a:p>
-            <a:pPr indent="0" marL="0">
-              <a:buNone/>
-            </a:pPr>
-            <a:r>
-              <a:rPr lang="en-US" sz="900" b="1" spc="100" kern="0" dirty="0">
-                <a:solidFill>
-                  <a:srgbClr val="1F6F57"/>
-                </a:solidFill>
-                <a:latin typeface="IBM Plex Mono" pitchFamily="34" charset="0"/>
-                <a:ea typeface="IBM Plex Mono" pitchFamily="34" charset="-122"/>
-                <a:cs typeface="IBM Plex Mono" pitchFamily="34" charset="-120"/>
-              </a:rPr>
-              <a:t>RESERVADO</a:t>
-            </a:r>
-            <a:endParaRPr lang="en-US" sz="900" dirty="0"/>
-          </a:p>
-        </p:txBody>
-      </p:sp>
-      <p:sp>
-        <p:nvSpPr>
-          <p:cNvPr id="13" name="Text 11"/>
-          <p:cNvSpPr txBox="1"/>
-          <p:nvPr/>
-        </p:nvSpPr>
-        <p:spPr>
-          <a:xfrm>
-            <a:off x="4370832" y="2670048"/>
-            <a:ext cx="2331720" cy="274320"/>
-          </a:xfrm>
-          <a:prstGeom prst="rect">
-            <a:avLst/>
-          </a:prstGeom>
-          <a:noFill/>
-          <a:ln/>
-        </p:spPr>
-        <p:txBody>
-          <a:bodyPr wrap="square" lIns="0" tIns="0" rIns="0" bIns="0" rtlCol="0" anchor="t"/>
-          <a:lstStyle/>
-          <a:p>
-            <a:pPr indent="0" marL="0">
-              <a:buNone/>
-            </a:pPr>
-            <a:r>
-              <a:rPr lang="en-US" sz="1200" dirty="0">
-                <a:solidFill>
-                  <a:srgbClr val="1F6F57"/>
-                </a:solidFill>
-                <a:latin typeface="IBM Plex Sans" pitchFamily="34" charset="0"/>
-                <a:ea typeface="IBM Plex Sans" pitchFamily="34" charset="-122"/>
-                <a:cs typeface="IBM Plex Sans" pitchFamily="34" charset="-120"/>
-              </a:rPr>
-              <a:t>2 de 4 personas</a:t>
-            </a:r>
-            <a:endParaRPr lang="en-US" sz="1200" dirty="0"/>
-          </a:p>
-        </p:txBody>
-      </p:sp>
-      <p:sp>
-        <p:nvSpPr>
-          <p:cNvPr id="14" name="Text 12"/>
-          <p:cNvSpPr txBox="1"/>
-          <p:nvPr/>
-        </p:nvSpPr>
-        <p:spPr>
-          <a:xfrm>
-            <a:off x="640080" y="3502152"/>
-            <a:ext cx="777240" cy="274320"/>
-          </a:xfrm>
-          <a:prstGeom prst="rect">
-            <a:avLst/>
-          </a:prstGeom>
-          <a:noFill/>
-          <a:ln/>
-        </p:spPr>
-        <p:txBody>
-          <a:bodyPr wrap="square" lIns="0" tIns="0" rIns="0" bIns="0" rtlCol="0" anchor="t"/>
-          <a:lstStyle/>
-          <a:p>
-            <a:pPr indent="0" marL="0">
-              <a:buNone/>
-            </a:pPr>
-            <a:r>
-              <a:rPr lang="en-US" sz="1100" spc="100" kern="0" dirty="0">
-                <a:solidFill>
-                  <a:srgbClr val="6A7B74"/>
-                </a:solidFill>
-                <a:latin typeface="IBM Plex Mono" pitchFamily="34" charset="0"/>
-                <a:ea typeface="IBM Plex Mono" pitchFamily="34" charset="-122"/>
-                <a:cs typeface="IBM Plex Mono" pitchFamily="34" charset="-120"/>
-              </a:rPr>
-              <a:t>18:30</a:t>
-            </a:r>
-            <a:endParaRPr lang="en-US" sz="1100" dirty="0"/>
-          </a:p>
-        </p:txBody>
-      </p:sp>
-      <p:sp>
-        <p:nvSpPr>
-          <p:cNvPr id="15" name="Reservado"/>
-          <p:cNvSpPr/>
-          <p:nvPr/>
-        </p:nvSpPr>
-        <p:spPr>
-          <a:xfrm>
-            <a:off x="1508760" y="3182112"/>
-            <a:ext cx="2606040" cy="896112"/>
-          </a:xfrm>
-          <a:prstGeom prst="roundRect">
-            <a:avLst>
-              <a:gd name="adj" fmla="val 10204"/>
-            </a:avLst>
-          </a:prstGeom>
-          <a:solidFill>
-            <a:srgbClr val="E8F4EE"/>
-          </a:solidFill>
-          <a:ln w="15875">
-            <a:solidFill>
-              <a:srgbClr val="BCDCCB"/>
-            </a:solidFill>
-            <a:prstDash val="solid"/>
-          </a:ln>
-        </p:spPr>
-      </p:sp>
-      <p:sp>
-        <p:nvSpPr>
-          <p:cNvPr id="16" name="Text 14"/>
-          <p:cNvSpPr txBox="1"/>
-          <p:nvPr/>
-        </p:nvSpPr>
-        <p:spPr>
-          <a:xfrm>
-            <a:off x="1673352" y="3337560"/>
-            <a:ext cx="2331720" cy="228600"/>
-          </a:xfrm>
-          <a:prstGeom prst="rect">
-            <a:avLst/>
-          </a:prstGeom>
-          <a:noFill/>
-          <a:ln/>
-        </p:spPr>
-        <p:txBody>
-          <a:bodyPr wrap="square" lIns="0" tIns="0" rIns="0" bIns="0" rtlCol="0" anchor="t"/>
-          <a:lstStyle/>
-          <a:p>
-            <a:pPr indent="0" marL="0">
-              <a:buNone/>
-            </a:pPr>
-            <a:r>
-              <a:rPr lang="en-US" sz="900" b="1" spc="100" kern="0" dirty="0">
-                <a:solidFill>
-                  <a:srgbClr val="1F6F57"/>
-                </a:solidFill>
-                <a:latin typeface="IBM Plex Mono" pitchFamily="34" charset="0"/>
-                <a:ea typeface="IBM Plex Mono" pitchFamily="34" charset="-122"/>
-                <a:cs typeface="IBM Plex Mono" pitchFamily="34" charset="-120"/>
-              </a:rPr>
-              <a:t>RESERVADO</a:t>
-            </a:r>
-            <a:endParaRPr lang="en-US" sz="900" dirty="0"/>
-          </a:p>
-        </p:txBody>
-      </p:sp>
-      <p:sp>
-        <p:nvSpPr>
-          <p:cNvPr id="17" name="Text 15"/>
-          <p:cNvSpPr txBox="1"/>
-          <p:nvPr/>
-        </p:nvSpPr>
-        <p:spPr>
-          <a:xfrm>
-            <a:off x="1673352" y="3657600"/>
-            <a:ext cx="2331720" cy="274320"/>
-          </a:xfrm>
-          <a:prstGeom prst="rect">
-            <a:avLst/>
-          </a:prstGeom>
-          <a:noFill/>
-          <a:ln/>
-        </p:spPr>
-        <p:txBody>
-          <a:bodyPr wrap="square" lIns="0" tIns="0" rIns="0" bIns="0" rtlCol="0" anchor="t"/>
-          <a:lstStyle/>
-          <a:p>
-            <a:pPr indent="0" marL="0">
-              <a:buNone/>
-            </a:pPr>
-            <a:r>
-              <a:rPr lang="en-US" sz="1200" dirty="0">
-                <a:solidFill>
-                  <a:srgbClr val="1F6F57"/>
-                </a:solidFill>
-                <a:latin typeface="IBM Plex Sans" pitchFamily="34" charset="0"/>
-                <a:ea typeface="IBM Plex Sans" pitchFamily="34" charset="-122"/>
-                <a:cs typeface="IBM Plex Sans" pitchFamily="34" charset="-120"/>
-              </a:rPr>
-              <a:t>2 de 4 personas</a:t>
-            </a:r>
-            <a:endParaRPr lang="en-US" sz="1200" dirty="0"/>
-          </a:p>
-        </p:txBody>
-      </p:sp>
-      <p:sp>
-        <p:nvSpPr>
-          <p:cNvPr id="18" name="Completo"/>
-          <p:cNvSpPr/>
-          <p:nvPr/>
-        </p:nvSpPr>
-        <p:spPr>
-          <a:xfrm>
-            <a:off x="4206240" y="3182112"/>
-            <a:ext cx="2606040" cy="896112"/>
-          </a:xfrm>
-          <a:prstGeom prst="roundRect">
-            <a:avLst>
-              <a:gd name="adj" fmla="val 10204"/>
-            </a:avLst>
-          </a:prstGeom>
-          <a:solidFill>
-            <a:srgbClr val="0F3D2E"/>
-          </a:solidFill>
-          <a:ln w="12700">
-            <a:solidFill>
-              <a:srgbClr val="0F3D2E"/>
-            </a:solidFill>
-            <a:prstDash val="solid"/>
-          </a:ln>
-        </p:spPr>
-      </p:sp>
-      <p:sp>
-        <p:nvSpPr>
-          <p:cNvPr id="19" name="Text 17"/>
-          <p:cNvSpPr txBox="1"/>
-          <p:nvPr/>
-        </p:nvSpPr>
-        <p:spPr>
-          <a:xfrm>
-            <a:off x="4370832" y="3337560"/>
-            <a:ext cx="2331720" cy="228600"/>
-          </a:xfrm>
-          <a:prstGeom prst="rect">
-            <a:avLst/>
-          </a:prstGeom>
-          <a:noFill/>
-          <a:ln/>
-        </p:spPr>
-        <p:txBody>
-          <a:bodyPr wrap="square" lIns="0" tIns="0" rIns="0" bIns="0" rtlCol="0" anchor="t"/>
-          <a:lstStyle/>
-          <a:p>
-            <a:pPr indent="0" marL="0">
-              <a:buNone/>
-            </a:pPr>
-            <a:r>
-              <a:rPr lang="en-US" sz="900" b="1" spc="100" kern="0" dirty="0">
-                <a:solidFill>
-                  <a:srgbClr val="FFFFFF"/>
-                </a:solidFill>
-                <a:latin typeface="IBM Plex Mono" pitchFamily="34" charset="0"/>
-                <a:ea typeface="IBM Plex Mono" pitchFamily="34" charset="-122"/>
-                <a:cs typeface="IBM Plex Mono" pitchFamily="34" charset="-120"/>
-              </a:rPr>
-              <a:t>COMPLETO</a:t>
-            </a:r>
-            <a:endParaRPr lang="en-US" sz="900" dirty="0"/>
-          </a:p>
-        </p:txBody>
-      </p:sp>
-      <p:sp>
-        <p:nvSpPr>
-          <p:cNvPr id="20" name="Text 18"/>
-          <p:cNvSpPr txBox="1"/>
-          <p:nvPr/>
-        </p:nvSpPr>
-        <p:spPr>
-          <a:xfrm>
-            <a:off x="4370832" y="3657600"/>
-            <a:ext cx="2331720" cy="274320"/>
-          </a:xfrm>
-          <a:prstGeom prst="rect">
-            <a:avLst/>
-          </a:prstGeom>
-          <a:noFill/>
-          <a:ln/>
-        </p:spPr>
-        <p:txBody>
-          <a:bodyPr wrap="square" lIns="0" tIns="0" rIns="0" bIns="0" rtlCol="0" anchor="t"/>
-          <a:lstStyle/>
-          <a:p>
-            <a:pPr indent="0" marL="0">
-              <a:buNone/>
-            </a:pPr>
-            <a:r>
-              <a:rPr lang="en-US" sz="1200" dirty="0">
-                <a:solidFill>
-                  <a:srgbClr val="A9D6C4"/>
-                </a:solidFill>
-                <a:latin typeface="IBM Plex Sans" pitchFamily="34" charset="0"/>
-                <a:ea typeface="IBM Plex Sans" pitchFamily="34" charset="-122"/>
-                <a:cs typeface="IBM Plex Sans" pitchFamily="34" charset="-120"/>
-              </a:rPr>
-              <a:t>4 de 4 personas</a:t>
-            </a:r>
-            <a:endParaRPr lang="en-US" sz="1200" dirty="0"/>
-          </a:p>
-        </p:txBody>
-      </p:sp>
-      <p:sp>
-        <p:nvSpPr>
-          <p:cNvPr id="21" name="Text 19"/>
-          <p:cNvSpPr txBox="1"/>
-          <p:nvPr/>
-        </p:nvSpPr>
-        <p:spPr>
-          <a:xfrm>
-            <a:off x="640080" y="4489704"/>
-            <a:ext cx="777240" cy="274320"/>
-          </a:xfrm>
-          <a:prstGeom prst="rect">
-            <a:avLst/>
-          </a:prstGeom>
-          <a:noFill/>
-          <a:ln/>
-        </p:spPr>
-        <p:txBody>
-          <a:bodyPr wrap="square" lIns="0" tIns="0" rIns="0" bIns="0" rtlCol="0" anchor="t"/>
-          <a:lstStyle/>
-          <a:p>
-            <a:pPr indent="0" marL="0">
-              <a:buNone/>
-            </a:pPr>
-            <a:r>
-              <a:rPr lang="en-US" sz="1100" spc="100" kern="0" dirty="0">
-                <a:solidFill>
-                  <a:srgbClr val="6A7B74"/>
-                </a:solidFill>
-                <a:latin typeface="IBM Plex Mono" pitchFamily="34" charset="0"/>
-                <a:ea typeface="IBM Plex Mono" pitchFamily="34" charset="-122"/>
-                <a:cs typeface="IBM Plex Mono" pitchFamily="34" charset="-120"/>
-              </a:rPr>
-              <a:t>20:00</a:t>
-            </a:r>
-            <a:endParaRPr lang="en-US" sz="1100" dirty="0"/>
-          </a:p>
-        </p:txBody>
-      </p:sp>
-      <p:sp>
-        <p:nvSpPr>
-          <p:cNvPr id="22" name="Completo"/>
-          <p:cNvSpPr/>
-          <p:nvPr/>
-        </p:nvSpPr>
-        <p:spPr>
-          <a:xfrm>
-            <a:off x="1508760" y="4169664"/>
-            <a:ext cx="2606040" cy="896112"/>
-          </a:xfrm>
-          <a:prstGeom prst="roundRect">
-            <a:avLst>
-              <a:gd name="adj" fmla="val 10204"/>
-            </a:avLst>
-          </a:prstGeom>
-          <a:solidFill>
-            <a:srgbClr val="0F3D2E"/>
-          </a:solidFill>
-          <a:ln w="12700">
-            <a:solidFill>
-              <a:srgbClr val="0F3D2E"/>
-            </a:solidFill>
-            <a:prstDash val="solid"/>
-          </a:ln>
-        </p:spPr>
-      </p:sp>
-      <p:sp>
-        <p:nvSpPr>
-          <p:cNvPr id="23" name="Text 21"/>
-          <p:cNvSpPr txBox="1"/>
-          <p:nvPr/>
-        </p:nvSpPr>
-        <p:spPr>
-          <a:xfrm>
-            <a:off x="1673352" y="4325112"/>
-            <a:ext cx="2331720" cy="228600"/>
-          </a:xfrm>
-          <a:prstGeom prst="rect">
-            <a:avLst/>
-          </a:prstGeom>
-          <a:noFill/>
-          <a:ln/>
-        </p:spPr>
-        <p:txBody>
-          <a:bodyPr wrap="square" lIns="0" tIns="0" rIns="0" bIns="0" rtlCol="0" anchor="t"/>
-          <a:lstStyle/>
-          <a:p>
-            <a:pPr indent="0" marL="0">
-              <a:buNone/>
-            </a:pPr>
-            <a:r>
-              <a:rPr lang="en-US" sz="900" b="1" spc="100" kern="0" dirty="0">
-                <a:solidFill>
-                  <a:srgbClr val="FFFFFF"/>
-                </a:solidFill>
-                <a:latin typeface="IBM Plex Mono" pitchFamily="34" charset="0"/>
-                <a:ea typeface="IBM Plex Mono" pitchFamily="34" charset="-122"/>
-                <a:cs typeface="IBM Plex Mono" pitchFamily="34" charset="-120"/>
-              </a:rPr>
-              <a:t>COMPLETO</a:t>
-            </a:r>
-            <a:endParaRPr lang="en-US" sz="900" dirty="0"/>
-          </a:p>
-        </p:txBody>
-      </p:sp>
-      <p:sp>
-        <p:nvSpPr>
-          <p:cNvPr id="24" name="Text 22"/>
-          <p:cNvSpPr txBox="1"/>
-          <p:nvPr/>
-        </p:nvSpPr>
-        <p:spPr>
-          <a:xfrm>
-            <a:off x="1673352" y="4645152"/>
-            <a:ext cx="2331720" cy="274320"/>
-          </a:xfrm>
-          <a:prstGeom prst="rect">
-            <a:avLst/>
-          </a:prstGeom>
-          <a:noFill/>
-          <a:ln/>
-        </p:spPr>
-        <p:txBody>
-          <a:bodyPr wrap="square" lIns="0" tIns="0" rIns="0" bIns="0" rtlCol="0" anchor="t"/>
-          <a:lstStyle/>
-          <a:p>
-            <a:pPr indent="0" marL="0">
-              <a:buNone/>
-            </a:pPr>
-            <a:r>
-              <a:rPr lang="en-US" sz="1200" dirty="0">
-                <a:solidFill>
-                  <a:srgbClr val="A9D6C4"/>
-                </a:solidFill>
-                <a:latin typeface="IBM Plex Sans" pitchFamily="34" charset="0"/>
-                <a:ea typeface="IBM Plex Sans" pitchFamily="34" charset="-122"/>
-                <a:cs typeface="IBM Plex Sans" pitchFamily="34" charset="-120"/>
-              </a:rPr>
-              <a:t>4 de 4 personas</a:t>
-            </a:r>
-            <a:endParaRPr lang="en-US" sz="1200" dirty="0"/>
-          </a:p>
-        </p:txBody>
-      </p:sp>
-      <p:sp>
-        <p:nvSpPr>
-          <p:cNvPr id="25" name="Cancelado"/>
-          <p:cNvSpPr/>
-          <p:nvPr/>
-        </p:nvSpPr>
-        <p:spPr>
-          <a:xfrm>
-            <a:off x="4206240" y="4169664"/>
-            <a:ext cx="2606040" cy="896112"/>
-          </a:xfrm>
-          <a:prstGeom prst="roundRect">
-            <a:avLst>
-              <a:gd name="adj" fmla="val 10204"/>
-            </a:avLst>
-          </a:prstGeom>
-          <a:solidFill>
-            <a:srgbClr val="FDEEEA"/>
-          </a:solidFill>
-          <a:ln w="15875">
-            <a:solidFill>
-              <a:srgbClr val="F4B9AD"/>
-            </a:solidFill>
-            <a:prstDash val="solid"/>
-          </a:ln>
-        </p:spPr>
-      </p:sp>
-      <p:sp>
-        <p:nvSpPr>
-          <p:cNvPr id="26" name="Text 24"/>
-          <p:cNvSpPr txBox="1"/>
-          <p:nvPr/>
-        </p:nvSpPr>
-        <p:spPr>
-          <a:xfrm>
-            <a:off x="4370832" y="4325112"/>
-            <a:ext cx="2331720" cy="228600"/>
-          </a:xfrm>
-          <a:prstGeom prst="rect">
-            <a:avLst/>
-          </a:prstGeom>
-          <a:noFill/>
-          <a:ln/>
-        </p:spPr>
-        <p:txBody>
-          <a:bodyPr wrap="square" lIns="0" tIns="0" rIns="0" bIns="0" rtlCol="0" anchor="t"/>
-          <a:lstStyle/>
-          <a:p>
-            <a:pPr indent="0" marL="0">
-              <a:buNone/>
-            </a:pPr>
-            <a:r>
-              <a:rPr lang="en-US" sz="900" b="1" spc="100" kern="0" dirty="0">
-                <a:solidFill>
-                  <a:srgbClr val="E5533D"/>
-                </a:solidFill>
-                <a:latin typeface="IBM Plex Mono" pitchFamily="34" charset="0"/>
-                <a:ea typeface="IBM Plex Mono" pitchFamily="34" charset="-122"/>
-                <a:cs typeface="IBM Plex Mono" pitchFamily="34" charset="-120"/>
-              </a:rPr>
-              <a:t>CANCELADO</a:t>
-            </a:r>
-            <a:endParaRPr lang="en-US" sz="900" dirty="0"/>
-          </a:p>
-        </p:txBody>
-      </p:sp>
-      <p:sp>
-        <p:nvSpPr>
-          <p:cNvPr id="27" name="Text 25"/>
-          <p:cNvSpPr txBox="1"/>
-          <p:nvPr/>
-        </p:nvSpPr>
-        <p:spPr>
-          <a:xfrm>
-            <a:off x="4370832" y="4645152"/>
-            <a:ext cx="2331720" cy="274320"/>
-          </a:xfrm>
-          <a:prstGeom prst="rect">
-            <a:avLst/>
-          </a:prstGeom>
-          <a:noFill/>
-          <a:ln/>
-        </p:spPr>
-        <p:txBody>
-          <a:bodyPr wrap="square" lIns="0" tIns="0" rIns="0" bIns="0" rtlCol="0" anchor="t"/>
-          <a:lstStyle/>
-          <a:p>
-            <a:pPr indent="0" marL="0">
-              <a:buNone/>
-            </a:pPr>
-            <a:r>
-              <a:rPr lang="en-US" sz="1200" dirty="0">
-                <a:solidFill>
-                  <a:srgbClr val="E5533D"/>
-                </a:solidFill>
-                <a:latin typeface="IBM Plex Sans" pitchFamily="34" charset="0"/>
-                <a:ea typeface="IBM Plex Sans" pitchFamily="34" charset="-122"/>
-                <a:cs typeface="IBM Plex Sans" pitchFamily="34" charset="-120"/>
-              </a:rPr>
-              <a:t>se guarda aparte</a:t>
-            </a:r>
-            <a:endParaRPr lang="en-US" sz="1200" dirty="0"/>
-          </a:p>
-        </p:txBody>
-      </p:sp>
-      <p:sp>
-        <p:nvSpPr>
-          <p:cNvPr id="28" name="Text 26"/>
-          <p:cNvSpPr txBox="1"/>
-          <p:nvPr/>
-        </p:nvSpPr>
-        <p:spPr>
-          <a:xfrm>
-            <a:off x="640080" y="5477256"/>
-            <a:ext cx="777240" cy="274320"/>
-          </a:xfrm>
-          <a:prstGeom prst="rect">
-            <a:avLst/>
-          </a:prstGeom>
-          <a:noFill/>
-          <a:ln/>
-        </p:spPr>
-        <p:txBody>
-          <a:bodyPr wrap="square" lIns="0" tIns="0" rIns="0" bIns="0" rtlCol="0" anchor="t"/>
-          <a:lstStyle/>
-          <a:p>
-            <a:pPr indent="0" marL="0">
-              <a:buNone/>
-            </a:pPr>
-            <a:r>
-              <a:rPr lang="en-US" sz="1100" spc="100" kern="0" dirty="0">
-                <a:solidFill>
-                  <a:srgbClr val="6A7B74"/>
-                </a:solidFill>
-                <a:latin typeface="IBM Plex Mono" pitchFamily="34" charset="0"/>
-                <a:ea typeface="IBM Plex Mono" pitchFamily="34" charset="-122"/>
-                <a:cs typeface="IBM Plex Mono" pitchFamily="34" charset="-120"/>
-              </a:rPr>
-              <a:t>21:30</a:t>
-            </a:r>
-            <a:endParaRPr lang="en-US" sz="1100" dirty="0"/>
-          </a:p>
-        </p:txBody>
-      </p:sp>
-      <p:sp>
-        <p:nvSpPr>
-          <p:cNvPr id="29" name="Libre"/>
-          <p:cNvSpPr/>
-          <p:nvPr/>
-        </p:nvSpPr>
-        <p:spPr>
-          <a:xfrm>
-            <a:off x="1508760" y="5157216"/>
+            <a:off x="4206240" y="5157216"/>
             <a:ext cx="2606040" cy="896112"/>
           </a:xfrm>
           <a:prstGeom prst="roundRect">
@@ -19819,13 +19924,13 @@
       </p:sp>
       <p:sp>
         <p:nvSpPr>
-          <p:cNvPr id="30" name="Text 28"/>
-          <p:cNvSpPr txBox="1"/>
-          <p:nvPr/>
-        </p:nvSpPr>
-        <p:spPr>
-          <a:xfrm>
-            <a:off x="1673352" y="5312664"/>
+          <p:cNvPr id="33" name="Text 31"/>
+          <p:cNvSpPr txBox="1"/>
+          <p:nvPr/>
+        </p:nvSpPr>
+        <p:spPr>
+          <a:xfrm>
+            <a:off x="4370832" y="5312664"/>
             <a:ext cx="2331720" cy="228600"/>
           </a:xfrm>
           <a:prstGeom prst="rect">
@@ -19858,13 +19963,13 @@
       </p:sp>
       <p:sp>
         <p:nvSpPr>
-          <p:cNvPr id="31" name="Text 29"/>
-          <p:cNvSpPr txBox="1"/>
-          <p:nvPr/>
-        </p:nvSpPr>
-        <p:spPr>
-          <a:xfrm>
-            <a:off x="1673352" y="5632704"/>
+          <p:cNvPr id="34" name="Text 32"/>
+          <p:cNvSpPr txBox="1"/>
+          <p:nvPr/>
+        </p:nvSpPr>
+        <p:spPr>
+          <a:xfrm>
+            <a:off x="4370832" y="5632704"/>
             <a:ext cx="2331720" cy="274320"/>
           </a:xfrm>
           <a:prstGeom prst="rect">
@@ -19889,112 +19994,7 @@
                 <a:ea typeface="IBM Plex Sans" pitchFamily="34" charset="-122"/>
                 <a:cs typeface="IBM Plex Sans" pitchFamily="34" charset="-120"/>
               </a:rPr>
-              <a:t>0 de 4 personas</a:t>
-            </a:r>
-            <a:endParaRPr lang="en-US" sz="1200" dirty="0"/>
-          </a:p>
-        </p:txBody>
-      </p:sp>
-      <p:sp>
-        <p:nvSpPr>
-          <p:cNvPr id="32" name="Reservado"/>
-          <p:cNvSpPr/>
-          <p:nvPr/>
-        </p:nvSpPr>
-        <p:spPr>
-          <a:xfrm>
-            <a:off x="4206240" y="5157216"/>
-            <a:ext cx="2606040" cy="896112"/>
-          </a:xfrm>
-          <a:prstGeom prst="roundRect">
-            <a:avLst>
-              <a:gd name="adj" fmla="val 10204"/>
-            </a:avLst>
-          </a:prstGeom>
-          <a:solidFill>
-            <a:srgbClr val="E8F4EE"/>
-          </a:solidFill>
-          <a:ln w="15875">
-            <a:solidFill>
-              <a:srgbClr val="BCDCCB"/>
-            </a:solidFill>
-            <a:prstDash val="solid"/>
-          </a:ln>
-        </p:spPr>
-      </p:sp>
-      <p:sp>
-        <p:nvSpPr>
-          <p:cNvPr id="33" name="Text 31"/>
-          <p:cNvSpPr txBox="1"/>
-          <p:nvPr/>
-        </p:nvSpPr>
-        <p:spPr>
-          <a:xfrm>
-            <a:off x="4370832" y="5312664"/>
-            <a:ext cx="2331720" cy="228600"/>
-          </a:xfrm>
-          <a:prstGeom prst="rect">
-            <a:avLst/>
-          </a:prstGeom>
-          <a:noFill/>
-          <a:ln/>
-        </p:spPr>
-        <p:txBody>
-          <a:bodyPr wrap="square" lIns="0" tIns="0" rIns="0" bIns="0" rtlCol="0" anchor="t"/>
-          <a:lstStyle/>
-          <a:p>
-            <a:pPr indent="0" marL="0">
-              <a:buNone/>
-            </a:pPr>
-            <a:r>
-              <a:rPr lang="en-US" sz="900" b="1" spc="100" kern="0" dirty="0">
-                <a:solidFill>
-                  <a:srgbClr val="1F6F57"/>
-                </a:solidFill>
-                <a:latin typeface="IBM Plex Mono" pitchFamily="34" charset="0"/>
-                <a:ea typeface="IBM Plex Mono" pitchFamily="34" charset="-122"/>
-                <a:cs typeface="IBM Plex Mono" pitchFamily="34" charset="-120"/>
-              </a:rPr>
-              <a:t>RESERVADO</a:t>
-            </a:r>
-            <a:endParaRPr lang="en-US" sz="900" dirty="0"/>
-          </a:p>
-        </p:txBody>
-      </p:sp>
-      <p:sp>
-        <p:nvSpPr>
-          <p:cNvPr id="34" name="Text 32"/>
-          <p:cNvSpPr txBox="1"/>
-          <p:nvPr/>
-        </p:nvSpPr>
-        <p:spPr>
-          <a:xfrm>
-            <a:off x="4370832" y="5632704"/>
-            <a:ext cx="2331720" cy="274320"/>
-          </a:xfrm>
-          <a:prstGeom prst="rect">
-            <a:avLst/>
-          </a:prstGeom>
-          <a:noFill/>
-          <a:ln/>
-        </p:spPr>
-        <p:txBody>
-          <a:bodyPr wrap="square" lIns="0" tIns="0" rIns="0" bIns="0" rtlCol="0" anchor="t"/>
-          <a:lstStyle/>
-          <a:p>
-            <a:pPr indent="0" marL="0">
-              <a:buNone/>
-            </a:pPr>
-            <a:r>
-              <a:rPr lang="en-US" sz="1200" dirty="0">
-                <a:solidFill>
-                  <a:srgbClr val="1F6F57"/>
-                </a:solidFill>
-                <a:latin typeface="IBM Plex Sans" pitchFamily="34" charset="0"/>
-                <a:ea typeface="IBM Plex Sans" pitchFamily="34" charset="-122"/>
-                <a:cs typeface="IBM Plex Sans" pitchFamily="34" charset="-120"/>
-              </a:rPr>
-              <a:t>3 de 4 personas</a:t>
+              <a:t>Tocá para reservar</a:t>
             </a:r>
             <a:endParaRPr lang="en-US" sz="1200" dirty="0"/>
           </a:p>
@@ -20134,7 +20134,7 @@
                 <a:ea typeface="IBM Plex Sans" pitchFamily="34" charset="-122"/>
                 <a:cs typeface="IBM Plex Sans" pitchFamily="34" charset="-120"/>
               </a:rPr>
-              <a:t>Borde punteado gris, fondo blanco. 0 personas.</a:t>
+              <a:t>Blanco con borde punteado gris. Sin personas.</a:t>
             </a:r>
             <a:endParaRPr lang="en-US" sz="1100" dirty="0"/>
           </a:p>
@@ -20274,7 +20274,7 @@
                 <a:ea typeface="IBM Plex Sans" pitchFamily="34" charset="-122"/>
                 <a:cs typeface="IBM Plex Sans" pitchFamily="34" charset="-120"/>
               </a:rPr>
-              <a:t>Fondo verde suave, texto verde. 1 a 3 personas.</a:t>
+              <a:t>Verde suave con borde punteado: hay personas, pero sin confirmar.</a:t>
             </a:r>
             <a:endParaRPr lang="en-US" sz="1100" dirty="0"/>
           </a:p>
@@ -20414,7 +20414,7 @@
                 <a:ea typeface="IBM Plex Sans" pitchFamily="34" charset="-122"/>
                 <a:cs typeface="IBM Plex Sans" pitchFamily="34" charset="-120"/>
               </a:rPr>
-              <a:t>Relleno verde bosque, texto blanco. 4 personas.</a:t>
+              <a:t>Verde bosque pleno: confirmado, listo para jugarse.</a:t>
             </a:r>
             <a:endParaRPr lang="en-US" sz="1100" dirty="0"/>
           </a:p>
@@ -20515,7 +20515,7 @@
                 <a:ea typeface="IBM Plex Sans" pitchFamily="34" charset="-122"/>
                 <a:cs typeface="IBM Plex Sans" pitchFamily="34" charset="-120"/>
               </a:rPr>
-              <a:t>Cancelado</a:t>
+              <a:t>Finalizado</a:t>
             </a:r>
             <a:endParaRPr lang="en-US" sz="1500" dirty="0"/>
           </a:p>
@@ -20554,7 +20554,7 @@
                 <a:ea typeface="IBM Plex Sans" pitchFamily="34" charset="-122"/>
                 <a:cs typeface="IBM Plex Sans" pitchFamily="34" charset="-120"/>
               </a:rPr>
-              <a:t>Chip coral. Se guarda aparte.</a:t>
+              <a:t>Azul cielo pleno con tilde: ya se jugó y se cobró.</a:t>
             </a:r>
             <a:endParaRPr lang="en-US" sz="1100" dirty="0"/>
           </a:p>
@@ -33405,7 +33405,7 @@
                 <a:ea typeface="IBM Plex Sans" pitchFamily="34" charset="-122"/>
                 <a:cs typeface="IBM Plex Sans" pitchFamily="34" charset="-120"/>
               </a:rPr>
-              <a:t>0 de 4 personas</a:t>
+              <a:t>Tocá para reservar</a:t>
             </a:r>
             <a:endParaRPr lang="en-US" sz="1200" dirty="0"/>
           </a:p>
@@ -33434,7 +33434,7 @@
             <a:solidFill>
               <a:srgbClr val="BCDCCB"/>
             </a:solidFill>
-            <a:prstDash val="solid"/>
+            <a:prstDash val="dash"/>
           </a:ln>
         </p:spPr>
       </p:sp>
@@ -33510,7 +33510,7 @@
                 <a:ea typeface="IBM Plex Sans" pitchFamily="34" charset="-122"/>
                 <a:cs typeface="IBM Plex Sans" pitchFamily="34" charset="-120"/>
               </a:rPr>
-              <a:t>2 de 4 personas</a:t>
+              <a:t>2 personas</a:t>
             </a:r>
             <a:endParaRPr lang="en-US" sz="1200" dirty="0"/>
           </a:p>
@@ -33615,7 +33615,7 @@
                 <a:ea typeface="IBM Plex Sans" pitchFamily="34" charset="-122"/>
                 <a:cs typeface="IBM Plex Sans" pitchFamily="34" charset="-120"/>
               </a:rPr>
-              <a:t>4 de 4 personas</a:t>
+              <a:t>5 personas</a:t>
             </a:r>
             <a:endParaRPr lang="en-US" sz="1200" dirty="0"/>
           </a:p>

</xml_diff>

<commit_message>
Mejoras generales. Falta configuración y vamos a back!
</commit_message>
<xml_diff>
--- a/Diseño/Manual de marca Pali.pptx
+++ b/Diseño/Manual de marca Pali.pptx
@@ -140,12 +140,12 @@
   <p:extLst>
     <p:ext uri="{521415D9-36F7-43E2-AB2F-B90AF26B5E84}">
       <p14:sectionLst xmlns:p14="http://schemas.microsoft.com/office/powerpoint/2010/main">
-        <p14:section name="Portada" id="{c78d5594-a6d6-fefa-1fdc-1183f09143b8}">
+        <p14:section name="Portada" id="{d57406a0-e983-5602-eb41-5e2301156798}">
           <p14:sldIdLst>
             <p14:sldId id="256"/>
           </p14:sldIdLst>
         </p14:section>
-        <p14:section name="Marca" id="{2394cc8d-de32-5828-2175-e86d501bf5bf}">
+        <p14:section name="Marca" id="{d5315d8c-1005-5a59-bd7a-ad3d2fd41e3f}">
           <p14:sldIdLst>
             <p14:sldId id="257"/>
             <p14:sldId id="258"/>
@@ -154,7 +154,7 @@
             <p14:sldId id="261"/>
           </p14:sldIdLst>
         </p14:section>
-        <p14:section name="Logo" id="{2bbe0201-dd1f-cba0-99c1-cc3792ee24fe}">
+        <p14:section name="Logo" id="{eb32dc9f-7e09-4872-fe58-3bed7dfe5872}">
           <p14:sldIdLst>
             <p14:sldId id="262"/>
             <p14:sldId id="263"/>
@@ -166,7 +166,7 @@
             <p14:sldId id="269"/>
           </p14:sldIdLst>
         </p14:section>
-        <p14:section name="Color" id="{bd2fe43d-0ce5-71fd-d498-f91a4d372de7}">
+        <p14:section name="Color" id="{d8a19ea0-d6cb-8fc2-700c-14a06e29c4a5}">
           <p14:sldIdLst>
             <p14:sldId id="270"/>
             <p14:sldId id="271"/>
@@ -179,7 +179,7 @@
             <p14:sldId id="278"/>
           </p14:sldIdLst>
         </p14:section>
-        <p14:section name="Tipografía" id="{b7facfc3-3ea2-ee08-d045-36d4d0f25cfd}">
+        <p14:section name="Tipografía" id="{83319fb9-a271-47a7-dcc2-bf293f5a5a05}">
           <p14:sldIdLst>
             <p14:sldId id="279"/>
             <p14:sldId id="280"/>
@@ -187,7 +187,7 @@
             <p14:sldId id="282"/>
           </p14:sldIdLst>
         </p14:section>
-        <p14:section name="Sistema" id="{5d21f891-6c1a-b59d-f6f5-54d44a24481c}">
+        <p14:section name="Sistema" id="{ddef8f3b-0475-5b76-a2f5-8bac2c7dc214}">
           <p14:sldIdLst>
             <p14:sldId id="283"/>
             <p14:sldId id="284"/>
@@ -197,7 +197,7 @@
             <p14:sldId id="288"/>
           </p14:sldIdLst>
         </p14:section>
-        <p14:section name="Cierre" id="{bebbbe01-c2ae-dae9-72f9-32cf0f513f4b}">
+        <p14:section name="Cierre" id="{fb0a0fef-a5bb-02ef-b3d1-4e4f96848e75}">
           <p14:sldIdLst>
             <p14:sldId id="289"/>
           </p14:sldIdLst>
@@ -32817,8 +32817,8 @@
         </p:nvSpPr>
         <p:spPr>
           <a:xfrm>
-            <a:off x="1325880" y="2724912"/>
-            <a:ext cx="1280160" cy="329184"/>
+            <a:off x="1298448" y="2724912"/>
+            <a:ext cx="1325880" cy="329184"/>
           </a:xfrm>
           <a:prstGeom prst="rect">
             <a:avLst/>
@@ -32834,7 +32834,7 @@
               <a:buNone/>
             </a:pPr>
             <a:r>
-              <a:rPr lang="en-US" sz="1300" dirty="0">
+              <a:rPr lang="en-US" sz="1100" dirty="0">
                 <a:solidFill>
                   <a:srgbClr val="FFFFFF"/>
                 </a:solidFill>
@@ -32842,9 +32842,9 @@
                 <a:ea typeface="IBM Plex Sans" pitchFamily="34" charset="-122"/>
                 <a:cs typeface="IBM Plex Sans" pitchFamily="34" charset="-120"/>
               </a:rPr>
-              <a:t>Cobros</a:t>
-            </a:r>
-            <a:endParaRPr lang="en-US" sz="1300" dirty="0"/>
+              <a:t>Resumen</a:t>
+            </a:r>
+            <a:endParaRPr lang="en-US" sz="1100" dirty="0"/>
           </a:p>
         </p:txBody>
       </p:sp>
@@ -32922,8 +32922,8 @@
         </p:nvSpPr>
         <p:spPr>
           <a:xfrm>
-            <a:off x="1325880" y="3182112"/>
-            <a:ext cx="1280160" cy="329184"/>
+            <a:off x="1298448" y="3182112"/>
+            <a:ext cx="1325880" cy="329184"/>
           </a:xfrm>
           <a:prstGeom prst="rect">
             <a:avLst/>
@@ -32939,7 +32939,7 @@
               <a:buNone/>
             </a:pPr>
             <a:r>
-              <a:rPr lang="en-US" sz="1300" b="1" dirty="0">
+              <a:rPr lang="en-US" sz="1100" b="1" dirty="0">
                 <a:solidFill>
                   <a:srgbClr val="0F3D2E"/>
                 </a:solidFill>
@@ -32947,9 +32947,9 @@
                 <a:ea typeface="IBM Plex Sans" pitchFamily="34" charset="-122"/>
                 <a:cs typeface="IBM Plex Sans" pitchFamily="34" charset="-120"/>
               </a:rPr>
-              <a:t>Agenda</a:t>
-            </a:r>
-            <a:endParaRPr lang="en-US" sz="1300" dirty="0"/>
+              <a:t>Turnos</a:t>
+            </a:r>
+            <a:endParaRPr lang="en-US" sz="1100" dirty="0"/>
           </a:p>
         </p:txBody>
       </p:sp>
@@ -33000,8 +33000,8 @@
         </p:nvSpPr>
         <p:spPr>
           <a:xfrm>
-            <a:off x="1325880" y="3639312"/>
-            <a:ext cx="1280160" cy="329184"/>
+            <a:off x="1298448" y="3639312"/>
+            <a:ext cx="1325880" cy="329184"/>
           </a:xfrm>
           <a:prstGeom prst="rect">
             <a:avLst/>
@@ -33017,7 +33017,7 @@
               <a:buNone/>
             </a:pPr>
             <a:r>
-              <a:rPr lang="en-US" sz="1300" dirty="0">
+              <a:rPr lang="en-US" sz="1100" dirty="0">
                 <a:solidFill>
                   <a:srgbClr val="FFFFFF"/>
                 </a:solidFill>
@@ -33025,9 +33025,9 @@
                 <a:ea typeface="IBM Plex Sans" pitchFamily="34" charset="-122"/>
                 <a:cs typeface="IBM Plex Sans" pitchFamily="34" charset="-120"/>
               </a:rPr>
-              <a:t>Personas</a:t>
-            </a:r>
-            <a:endParaRPr lang="en-US" sz="1300" dirty="0"/>
+              <a:t>Jugadores</a:t>
+            </a:r>
+            <a:endParaRPr lang="en-US" sz="1100" dirty="0"/>
           </a:p>
         </p:txBody>
       </p:sp>
@@ -33078,8 +33078,8 @@
         </p:nvSpPr>
         <p:spPr>
           <a:xfrm>
-            <a:off x="1325880" y="4096512"/>
-            <a:ext cx="1280160" cy="329184"/>
+            <a:off x="1298448" y="4096512"/>
+            <a:ext cx="1325880" cy="329184"/>
           </a:xfrm>
           <a:prstGeom prst="rect">
             <a:avLst/>
@@ -33095,7 +33095,7 @@
               <a:buNone/>
             </a:pPr>
             <a:r>
-              <a:rPr lang="en-US" sz="1300" dirty="0">
+              <a:rPr lang="en-US" sz="1100" dirty="0">
                 <a:solidFill>
                   <a:srgbClr val="FFFFFF"/>
                 </a:solidFill>
@@ -33103,93 +33103,15 @@
                 <a:ea typeface="IBM Plex Sans" pitchFamily="34" charset="-122"/>
                 <a:cs typeface="IBM Plex Sans" pitchFamily="34" charset="-120"/>
               </a:rPr>
-              <a:t>Reservas</a:t>
-            </a:r>
-            <a:endParaRPr lang="en-US" sz="1300" dirty="0"/>
-          </a:p>
-        </p:txBody>
-      </p:sp>
-      <p:sp>
-        <p:nvSpPr>
-          <p:cNvPr id="17" name="Text 14"/>
-          <p:cNvSpPr txBox="1"/>
-          <p:nvPr/>
-        </p:nvSpPr>
-        <p:spPr>
-          <a:xfrm>
-            <a:off x="914400" y="4553712"/>
-            <a:ext cx="365760" cy="329184"/>
-          </a:xfrm>
-          <a:prstGeom prst="rect">
-            <a:avLst/>
-          </a:prstGeom>
-          <a:noFill/>
-          <a:ln/>
-        </p:spPr>
-        <p:txBody>
-          <a:bodyPr wrap="square" lIns="0" tIns="0" rIns="0" bIns="0" rtlCol="0" anchor="ctr"/>
-          <a:lstStyle/>
-          <a:p>
-            <a:pPr indent="0" marL="0">
-              <a:buNone/>
-            </a:pPr>
-            <a:r>
-              <a:rPr lang="en-US" sz="1000" spc="100" kern="0" dirty="0">
-                <a:solidFill>
-                  <a:srgbClr val="A9D6C4"/>
-                </a:solidFill>
-                <a:latin typeface="IBM Plex Mono" pitchFamily="34" charset="0"/>
-                <a:ea typeface="IBM Plex Mono" pitchFamily="34" charset="-122"/>
-                <a:cs typeface="IBM Plex Mono" pitchFamily="34" charset="-120"/>
-              </a:rPr>
-              <a:t>05</a:t>
-            </a:r>
-            <a:endParaRPr lang="en-US" sz="1000" dirty="0"/>
-          </a:p>
-        </p:txBody>
-      </p:sp>
-      <p:sp>
-        <p:nvSpPr>
-          <p:cNvPr id="18" name="Text 15"/>
-          <p:cNvSpPr txBox="1"/>
-          <p:nvPr/>
-        </p:nvSpPr>
-        <p:spPr>
-          <a:xfrm>
-            <a:off x="1325880" y="4553712"/>
-            <a:ext cx="1280160" cy="329184"/>
-          </a:xfrm>
-          <a:prstGeom prst="rect">
-            <a:avLst/>
-          </a:prstGeom>
-          <a:noFill/>
-          <a:ln/>
-        </p:spPr>
-        <p:txBody>
-          <a:bodyPr wrap="square" lIns="0" tIns="0" rIns="0" bIns="0" rtlCol="0" anchor="ctr"/>
-          <a:lstStyle/>
-          <a:p>
-            <a:pPr indent="0" marL="0">
-              <a:buNone/>
-            </a:pPr>
-            <a:r>
-              <a:rPr lang="en-US" sz="1300" dirty="0">
-                <a:solidFill>
-                  <a:srgbClr val="FFFFFF"/>
-                </a:solidFill>
-                <a:latin typeface="IBM Plex Sans" pitchFamily="34" charset="0"/>
-                <a:ea typeface="IBM Plex Sans" pitchFamily="34" charset="-122"/>
-                <a:cs typeface="IBM Plex Sans" pitchFamily="34" charset="-120"/>
-              </a:rPr>
               <a:t>Configuración</a:t>
             </a:r>
-            <a:endParaRPr lang="en-US" sz="1300" dirty="0"/>
-          </a:p>
-        </p:txBody>
-      </p:sp>
-      <p:sp>
-        <p:nvSpPr>
-          <p:cNvPr id="19" name="Encabezado de página"/>
+            <a:endParaRPr lang="en-US" sz="1100" dirty="0"/>
+          </a:p>
+        </p:txBody>
+      </p:sp>
+      <p:sp>
+        <p:nvSpPr>
+          <p:cNvPr id="17" name="Encabezado de página"/>
           <p:cNvSpPr/>
           <p:nvPr/>
         </p:nvSpPr>
@@ -33216,7 +33138,7 @@
       </p:sp>
       <p:sp>
         <p:nvSpPr>
-          <p:cNvPr id="20" name="Text 17"/>
+          <p:cNvPr id="18" name="Text 15"/>
           <p:cNvSpPr txBox="1"/>
           <p:nvPr/>
         </p:nvSpPr>
@@ -33247,7 +33169,7 @@
                 <a:ea typeface="IBM Plex Mono" pitchFamily="34" charset="-122"/>
                 <a:cs typeface="IBM Plex Mono" pitchFamily="34" charset="-120"/>
               </a:rPr>
-              <a:t>BACKOFFICE · AGENDA</a:t>
+              <a:t>BACKOFFICE · TURNOS</a:t>
             </a:r>
             <a:endParaRPr lang="en-US" sz="900" dirty="0"/>
           </a:p>
@@ -33255,7 +33177,7 @@
       </p:sp>
       <p:sp>
         <p:nvSpPr>
-          <p:cNvPr id="21" name="Text 18"/>
+          <p:cNvPr id="19" name="Text 16"/>
           <p:cNvSpPr txBox="1"/>
           <p:nvPr/>
         </p:nvSpPr>
@@ -33308,7 +33230,7 @@
       </p:sp>
       <p:sp>
         <p:nvSpPr>
-          <p:cNvPr id="22" name="Turno Libre"/>
+          <p:cNvPr id="20" name="Turno Libre"/>
           <p:cNvSpPr/>
           <p:nvPr/>
         </p:nvSpPr>
@@ -33335,7 +33257,7 @@
       </p:sp>
       <p:sp>
         <p:nvSpPr>
-          <p:cNvPr id="23" name="Text 20"/>
+          <p:cNvPr id="21" name="Text 18"/>
           <p:cNvSpPr txBox="1"/>
           <p:nvPr/>
         </p:nvSpPr>
@@ -33374,7 +33296,7 @@
       </p:sp>
       <p:sp>
         <p:nvSpPr>
-          <p:cNvPr id="24" name="Text 21"/>
+          <p:cNvPr id="22" name="Text 19"/>
           <p:cNvSpPr txBox="1"/>
           <p:nvPr/>
         </p:nvSpPr>
@@ -33413,7 +33335,7 @@
       </p:sp>
       <p:sp>
         <p:nvSpPr>
-          <p:cNvPr id="25" name="Turno Reservado"/>
+          <p:cNvPr id="23" name="Turno Reservado"/>
           <p:cNvSpPr/>
           <p:nvPr/>
         </p:nvSpPr>
@@ -33440,7 +33362,7 @@
       </p:sp>
       <p:sp>
         <p:nvSpPr>
-          <p:cNvPr id="26" name="Text 23"/>
+          <p:cNvPr id="24" name="Text 21"/>
           <p:cNvSpPr txBox="1"/>
           <p:nvPr/>
         </p:nvSpPr>
@@ -33479,7 +33401,7 @@
       </p:sp>
       <p:sp>
         <p:nvSpPr>
-          <p:cNvPr id="27" name="Text 24"/>
+          <p:cNvPr id="25" name="Text 22"/>
           <p:cNvSpPr txBox="1"/>
           <p:nvPr/>
         </p:nvSpPr>
@@ -33518,7 +33440,7 @@
       </p:sp>
       <p:sp>
         <p:nvSpPr>
-          <p:cNvPr id="28" name="Turno Completo"/>
+          <p:cNvPr id="26" name="Turno Completo"/>
           <p:cNvSpPr/>
           <p:nvPr/>
         </p:nvSpPr>
@@ -33545,7 +33467,7 @@
       </p:sp>
       <p:sp>
         <p:nvSpPr>
-          <p:cNvPr id="29" name="Text 26"/>
+          <p:cNvPr id="27" name="Text 24"/>
           <p:cNvSpPr txBox="1"/>
           <p:nvPr/>
         </p:nvSpPr>
@@ -33584,7 +33506,7 @@
       </p:sp>
       <p:sp>
         <p:nvSpPr>
-          <p:cNvPr id="30" name="Text 27"/>
+          <p:cNvPr id="28" name="Text 25"/>
           <p:cNvSpPr txBox="1"/>
           <p:nvPr/>
         </p:nvSpPr>
@@ -33623,7 +33545,7 @@
       </p:sp>
       <p:sp>
         <p:nvSpPr>
-          <p:cNvPr id="31" name="Chip categoría"/>
+          <p:cNvPr id="29" name="Chip categoría"/>
           <p:cNvSpPr/>
           <p:nvPr/>
         </p:nvSpPr>
@@ -33650,7 +33572,7 @@
       </p:sp>
       <p:sp>
         <p:nvSpPr>
-          <p:cNvPr id="32" name="Text 29"/>
+          <p:cNvPr id="30" name="Text 27"/>
           <p:cNvSpPr txBox="1"/>
           <p:nvPr/>
         </p:nvSpPr>
@@ -33689,7 +33611,7 @@
       </p:sp>
       <p:sp>
         <p:nvSpPr>
-          <p:cNvPr id="33" name="Chip cancha"/>
+          <p:cNvPr id="31" name="Chip cancha"/>
           <p:cNvSpPr/>
           <p:nvPr/>
         </p:nvSpPr>
@@ -33716,7 +33638,7 @@
       </p:sp>
       <p:sp>
         <p:nvSpPr>
-          <p:cNvPr id="34" name="Text 31"/>
+          <p:cNvPr id="32" name="Text 29"/>
           <p:cNvSpPr txBox="1"/>
           <p:nvPr/>
         </p:nvSpPr>
@@ -33755,7 +33677,7 @@
       </p:sp>
       <p:sp>
         <p:nvSpPr>
-          <p:cNvPr id="35" name="Botón Reservar"/>
+          <p:cNvPr id="33" name="Botón Reservar"/>
           <p:cNvSpPr/>
           <p:nvPr/>
         </p:nvSpPr>
@@ -33782,7 +33704,7 @@
       </p:sp>
       <p:sp>
         <p:nvSpPr>
-          <p:cNvPr id="36" name="Text 33"/>
+          <p:cNvPr id="34" name="Text 31"/>
           <p:cNvSpPr txBox="1"/>
           <p:nvPr/>
         </p:nvSpPr>
@@ -33821,7 +33743,7 @@
       </p:sp>
       <p:sp>
         <p:nvSpPr>
-          <p:cNvPr id="37" name="Botón Aceptar"/>
+          <p:cNvPr id="35" name="Botón Aceptar"/>
           <p:cNvSpPr/>
           <p:nvPr/>
         </p:nvSpPr>
@@ -33848,7 +33770,7 @@
       </p:sp>
       <p:sp>
         <p:nvSpPr>
-          <p:cNvPr id="38" name="Text 35"/>
+          <p:cNvPr id="36" name="Text 33"/>
           <p:cNvSpPr txBox="1"/>
           <p:nvPr/>
         </p:nvSpPr>
@@ -33887,7 +33809,7 @@
       </p:sp>
       <p:sp>
         <p:nvSpPr>
-          <p:cNvPr id="39" name="Botón Cancelar"/>
+          <p:cNvPr id="37" name="Botón Cancelar"/>
           <p:cNvSpPr/>
           <p:nvPr/>
         </p:nvSpPr>
@@ -33914,7 +33836,7 @@
       </p:sp>
       <p:sp>
         <p:nvSpPr>
-          <p:cNvPr id="40" name="Text 37"/>
+          <p:cNvPr id="38" name="Text 35"/>
           <p:cNvSpPr txBox="1"/>
           <p:nvPr/>
         </p:nvSpPr>
@@ -33953,7 +33875,7 @@
       </p:sp>
       <p:sp>
         <p:nvSpPr>
-          <p:cNvPr id="41" name="Botón Cancelar turno"/>
+          <p:cNvPr id="39" name="Botón Cancelar turno"/>
           <p:cNvSpPr/>
           <p:nvPr/>
         </p:nvSpPr>
@@ -33980,7 +33902,7 @@
       </p:sp>
       <p:sp>
         <p:nvSpPr>
-          <p:cNvPr id="42" name="Text 39"/>
+          <p:cNvPr id="40" name="Text 37"/>
           <p:cNvSpPr txBox="1"/>
           <p:nvPr/>
         </p:nvSpPr>
@@ -34019,7 +33941,7 @@
       </p:sp>
       <p:sp>
         <p:nvSpPr>
-          <p:cNvPr id="43" name="Filete"/>
+          <p:cNvPr id="41" name="Filete"/>
           <p:cNvSpPr/>
           <p:nvPr/>
         </p:nvSpPr>
@@ -34042,7 +33964,7 @@
       </p:sp>
       <p:sp>
         <p:nvSpPr>
-          <p:cNvPr id="44" name="Text 41"/>
+          <p:cNvPr id="42" name="Text 39"/>
           <p:cNvSpPr txBox="1"/>
           <p:nvPr/>
         </p:nvSpPr>
@@ -34081,7 +34003,7 @@
       </p:sp>
       <p:sp>
         <p:nvSpPr>
-          <p:cNvPr id="45" name="Text 42"/>
+          <p:cNvPr id="43" name="Text 40"/>
           <p:cNvSpPr txBox="1"/>
           <p:nvPr/>
         </p:nvSpPr>
@@ -34120,7 +34042,7 @@
       </p:sp>
       <p:sp>
         <p:nvSpPr>
-          <p:cNvPr id="46" name="Text 43"/>
+          <p:cNvPr id="44" name="Text 41"/>
           <p:cNvSpPr txBox="1"/>
           <p:nvPr/>
         </p:nvSpPr>
@@ -34159,7 +34081,7 @@
       </p:sp>
       <p:sp>
         <p:nvSpPr>
-          <p:cNvPr id="47" name="Filete"/>
+          <p:cNvPr id="45" name="Filete"/>
           <p:cNvSpPr/>
           <p:nvPr/>
         </p:nvSpPr>
@@ -34182,7 +34104,7 @@
       </p:sp>
       <p:sp>
         <p:nvSpPr>
-          <p:cNvPr id="48" name="Text 45"/>
+          <p:cNvPr id="46" name="Text 43"/>
           <p:cNvSpPr txBox="1"/>
           <p:nvPr/>
         </p:nvSpPr>
@@ -34221,7 +34143,7 @@
       </p:sp>
       <p:sp>
         <p:nvSpPr>
-          <p:cNvPr id="49" name="Text 46"/>
+          <p:cNvPr id="47" name="Text 44"/>
           <p:cNvSpPr txBox="1"/>
           <p:nvPr/>
         </p:nvSpPr>
@@ -34260,7 +34182,7 @@
       </p:sp>
       <p:sp>
         <p:nvSpPr>
-          <p:cNvPr id="50" name="Text 47"/>
+          <p:cNvPr id="48" name="Text 45"/>
           <p:cNvSpPr txBox="1"/>
           <p:nvPr/>
         </p:nvSpPr>
@@ -34299,7 +34221,7 @@
       </p:sp>
       <p:sp>
         <p:nvSpPr>
-          <p:cNvPr id="51" name="Filete"/>
+          <p:cNvPr id="49" name="Filete"/>
           <p:cNvSpPr/>
           <p:nvPr/>
         </p:nvSpPr>
@@ -34322,7 +34244,7 @@
       </p:sp>
       <p:sp>
         <p:nvSpPr>
-          <p:cNvPr id="52" name="Text 49"/>
+          <p:cNvPr id="50" name="Text 47"/>
           <p:cNvSpPr txBox="1"/>
           <p:nvPr/>
         </p:nvSpPr>
@@ -34361,7 +34283,7 @@
       </p:sp>
       <p:sp>
         <p:nvSpPr>
-          <p:cNvPr id="53" name="Text 50"/>
+          <p:cNvPr id="51" name="Text 48"/>
           <p:cNvSpPr txBox="1"/>
           <p:nvPr/>
         </p:nvSpPr>
@@ -34400,7 +34322,7 @@
       </p:sp>
       <p:sp>
         <p:nvSpPr>
-          <p:cNvPr id="54" name="Text 51"/>
+          <p:cNvPr id="52" name="Text 49"/>
           <p:cNvSpPr txBox="1"/>
           <p:nvPr/>
         </p:nvSpPr>
@@ -34439,7 +34361,7 @@
       </p:sp>
       <p:sp>
         <p:nvSpPr>
-          <p:cNvPr id="55" name="Filete"/>
+          <p:cNvPr id="53" name="Filete"/>
           <p:cNvSpPr/>
           <p:nvPr/>
         </p:nvSpPr>
@@ -34462,7 +34384,7 @@
       </p:sp>
       <p:sp>
         <p:nvSpPr>
-          <p:cNvPr id="56" name="Text 53"/>
+          <p:cNvPr id="54" name="Text 51"/>
           <p:cNvSpPr txBox="1"/>
           <p:nvPr/>
         </p:nvSpPr>
@@ -34501,7 +34423,7 @@
       </p:sp>
       <p:sp>
         <p:nvSpPr>
-          <p:cNvPr id="57" name="Text 54"/>
+          <p:cNvPr id="55" name="Text 52"/>
           <p:cNvSpPr txBox="1"/>
           <p:nvPr/>
         </p:nvSpPr>
@@ -34540,7 +34462,7 @@
       </p:sp>
       <p:sp>
         <p:nvSpPr>
-          <p:cNvPr id="58" name="Text 55"/>
+          <p:cNvPr id="56" name="Text 53"/>
           <p:cNvSpPr txBox="1"/>
           <p:nvPr/>
         </p:nvSpPr>
@@ -34579,7 +34501,7 @@
       </p:sp>
       <p:sp>
         <p:nvSpPr>
-          <p:cNvPr id="59" name="Filete"/>
+          <p:cNvPr id="57" name="Filete"/>
           <p:cNvSpPr/>
           <p:nvPr/>
         </p:nvSpPr>
@@ -34602,7 +34524,7 @@
       </p:sp>
       <p:sp>
         <p:nvSpPr>
-          <p:cNvPr id="60" name="Text 57"/>
+          <p:cNvPr id="58" name="Text 55"/>
           <p:cNvSpPr txBox="1"/>
           <p:nvPr/>
         </p:nvSpPr>
@@ -34641,7 +34563,7 @@
       </p:sp>
       <p:sp>
         <p:nvSpPr>
-          <p:cNvPr id="61" name="Text 58"/>
+          <p:cNvPr id="59" name="Text 56"/>
           <p:cNvSpPr txBox="1"/>
           <p:nvPr/>
         </p:nvSpPr>
@@ -34680,7 +34602,7 @@
       </p:sp>
       <p:sp>
         <p:nvSpPr>
-          <p:cNvPr id="62" name="Text 59"/>
+          <p:cNvPr id="60" name="Text 57"/>
           <p:cNvSpPr txBox="1"/>
           <p:nvPr/>
         </p:nvSpPr>

</xml_diff>